<commit_message>
chore(preview): indice_SP_500 outputs regeneres
</commit_message>
<xml_diff>
--- a/preview/indice_SP_500/indice_SP_500.pptx
+++ b/preview/indice_SP_500/indice_SP_500.pptx
@@ -3469,7 +3469,7 @@
                   <a:srgbClr val="FFFFFF"/>
                 </a:solidFill>
               </a:rPr>
-              <a:t>6 400</a:t>
+              <a:t>6 390</a:t>
             </a:r>
           </a:p>
         </p:txBody>
@@ -3580,7 +3580,7 @@
                   <a:srgbClr val="FFFFFF"/>
                 </a:solidFill>
               </a:rPr>
-              <a:t>-6.7%</a:t>
+              <a:t>-6.8%</a:t>
             </a:r>
           </a:p>
         </p:txBody>
@@ -6407,7 +6407,7 @@
                             <a:srgbClr val="1A1A1A"/>
                           </a:solidFill>
                         </a:rPr>
-                        <a:t>Consumer Staples</a:t>
+                        <a:t>Cons. Staples</a:t>
                       </a:r>
                     </a:p>
                   </a:txBody>
@@ -9735,7 +9735,7 @@
                   <a:srgbClr val="555555"/>
                 </a:solidFill>
               </a:rPr>
-              <a:t>Performance YTD +25.0% — momentum sectoriel positif</a:t>
+              <a:t>Performance YTD +24.6% — momentum sectoriel positif</a:t>
             </a:r>
           </a:p>
         </p:txBody>
@@ -10759,7 +10759,7 @@
                   <a:srgbClr val="555555"/>
                 </a:solidFill>
               </a:rPr>
-              <a:t>Performance YTD +23.7% — momentum sectoriel positif</a:t>
+              <a:t>Performance YTD +23.3% — momentum sectoriel positif</a:t>
             </a:r>
           </a:p>
         </p:txBody>
@@ -15256,7 +15256,7 @@
                             <a:srgbClr val="1A1A1A"/>
                           </a:solidFill>
                         </a:rPr>
-                        <a:t>Communication Servic</a:t>
+                        <a:t>Comm. Services</a:t>
                       </a:r>
                     </a:p>
                   </a:txBody>
@@ -15368,7 +15368,7 @@
                             <a:srgbClr val="1A1A1A"/>
                           </a:solidFill>
                         </a:rPr>
-                        <a:t>Consumer Discretiona</a:t>
+                        <a:t>Cons. Discret.</a:t>
                       </a:r>
                     </a:p>
                   </a:txBody>
@@ -15584,7 +15584,7 @@
                             <a:srgbClr val="1A1A1A"/>
                           </a:solidFill>
                         </a:rPr>
-                        <a:t>Consumer Staples</a:t>
+                        <a:t>Cons. Staples</a:t>
                       </a:r>
                     </a:p>
                   </a:txBody>
@@ -16851,7 +16851,7 @@
                   <a:srgbClr val="555555"/>
                 </a:solidFill>
               </a:rPr>
-              <a:t>Analyse semantique FinBERT  ·  420 articles  ·  7 jours glissants  ·  11 secteurs</a:t>
+              <a:t>Analyse semantique FinBERT  ·  34 articles  ·  7 jours glissants  ·  11 secteurs</a:t>
             </a:r>
           </a:p>
         </p:txBody>
@@ -17096,7 +17096,7 @@
         <p:spPr>
           <a:xfrm>
             <a:off x="2592000" y="827999"/>
-            <a:ext cx="1123200" cy="360000"/>
+            <a:ext cx="1235520" cy="360000"/>
           </a:xfrm>
           <a:prstGeom prst="rect">
             <a:avLst/>
@@ -17193,7 +17193,7 @@
                   <a:srgbClr val="FFFFFF"/>
                 </a:solidFill>
               </a:rPr>
-              <a:t>168 articles (40 %)</a:t>
+              <a:t>15 articles (44 %)</a:t>
             </a:r>
           </a:p>
         </p:txBody>
@@ -17250,7 +17250,7 @@
         <p:spPr>
           <a:xfrm>
             <a:off x="2592000" y="1242000"/>
-            <a:ext cx="1263600" cy="360000"/>
+            <a:ext cx="982800" cy="360000"/>
           </a:xfrm>
           <a:prstGeom prst="rect">
             <a:avLst/>
@@ -17347,7 +17347,7 @@
                   <a:srgbClr val="FFFFFF"/>
                 </a:solidFill>
               </a:rPr>
-              <a:t>189 articles (45 %)</a:t>
+              <a:t>12 articles (35 %)</a:t>
             </a:r>
           </a:p>
         </p:txBody>
@@ -17404,7 +17404,7 @@
         <p:spPr>
           <a:xfrm>
             <a:off x="2592000" y="1655999"/>
-            <a:ext cx="421200" cy="360000"/>
+            <a:ext cx="589680" cy="360000"/>
           </a:xfrm>
           <a:prstGeom prst="rect">
             <a:avLst/>
@@ -17501,7 +17501,7 @@
                   <a:srgbClr val="FFFFFF"/>
                 </a:solidFill>
               </a:rPr>
-              <a:t>63 articles (15 %)</a:t>
+              <a:t>7 articles (21 %)</a:t>
             </a:r>
           </a:p>
         </p:txBody>
@@ -17612,7 +17612,7 @@
                   <a:srgbClr val="555555"/>
                 </a:solidFill>
               </a:rPr>
-              <a:t>+ —</a:t>
+              <a:t>+ Resultats T4  ·  Cycle IA  ·  Innovation semi</a:t>
             </a:r>
           </a:p>
         </p:txBody>
@@ -17689,7 +17689,7 @@
                   <a:srgbClr val="555555"/>
                 </a:solidFill>
               </a:rPr>
-              <a:t>- —</a:t>
+              <a:t>- Regulation  ·  Taux LT  ·  CRE</a:t>
             </a:r>
           </a:p>
         </p:txBody>
@@ -18449,7 +18449,7 @@
                   <a:srgbClr val="555555"/>
                 </a:solidFill>
               </a:rPr>
-              <a:t>Cours : 6 400  ·  YTD : -6.7%  ·  P/E Forward : —  ·  Croissance BPA : +8.5%  ·  Conviction 55 %</a:t>
+              <a:t>Cours : 6 390  ·  YTD : -6.8%  ·  P/E Forward : —  ·  Croissance BPA : +8.5%  ·  Conviction 55 %</a:t>
             </a:r>
           </a:p>
         </p:txBody>
@@ -19013,7 +19013,7 @@
                   <a:srgbClr val="555555"/>
                 </a:solidFill>
               </a:rPr>
-              <a:t>Le signal global sur le S&amp;P 500 est Neutre avec une conviction de 27% (sur la base des 11 secteurs analyses). 3 secteurs ressortent Surponderer — Technology, Health Care et Financials — portes respectivement par le cycle IA, le pricing power defensif et les spreads de credit eleves. 6 secteurs sont Neutre en raison d'une visibilite limitee sur les BPA dans un contexte de taux restrictifs. 2 secteu</a:t>
+              <a:t>Le signal global sur le S&amp;P 500 est Surponderer avec une conviction de 55% (sur la base des 11 secteurs analyses). 6 secteur(s) ressortent Surponderer — Technology, Communication Servic, Industrials — portes par leur momentum positif 52 semaines. 5 secteurs sont Neutre et 0 en Sous-ponderer.</a:t>
             </a:r>
           </a:p>
         </p:txBody>
@@ -19970,7 +19970,7 @@
                   <a:srgbClr val="1A7A4A"/>
                 </a:solidFill>
               </a:rPr>
-              <a:t>+25.0 %</a:t>
+              <a:t>+24.6 %</a:t>
             </a:r>
           </a:p>
         </p:txBody>
@@ -20081,7 +20081,7 @@
                   <a:srgbClr val="1A7A4A"/>
                 </a:solidFill>
               </a:rPr>
-              <a:t>+23.7 %</a:t>
+              <a:t>+23.3 %</a:t>
             </a:r>
           </a:p>
         </p:txBody>
@@ -20192,7 +20192,7 @@
                   <a:srgbClr val="1A7A4A"/>
                 </a:solidFill>
               </a:rPr>
-              <a:t>+19.7 %</a:t>
+              <a:t>+19.8 %</a:t>
             </a:r>
           </a:p>
         </p:txBody>
@@ -20414,7 +20414,7 @@
                   <a:srgbClr val="1A7A4A"/>
                 </a:solidFill>
               </a:rPr>
-              <a:t>+13.7 %</a:t>
+              <a:t>+13.4 %</a:t>
             </a:r>
           </a:p>
         </p:txBody>
@@ -20525,7 +20525,7 @@
                   <a:srgbClr val="1A7A4A"/>
                 </a:solidFill>
               </a:rPr>
-              <a:t>+8.7 %</a:t>
+              <a:t>+8.4 %</a:t>
             </a:r>
           </a:p>
         </p:txBody>
@@ -20636,7 +20636,7 @@
                   <a:srgbClr val="1A7A4A"/>
                 </a:solidFill>
               </a:rPr>
-              <a:t>+4.4 %</a:t>
+              <a:t>+4.5 %</a:t>
             </a:r>
           </a:p>
         </p:txBody>
@@ -23240,7 +23240,7 @@
                             <a:srgbClr val="1A1A1A"/>
                           </a:solidFill>
                         </a:rPr>
-                        <a:t>6 400</a:t>
+                        <a:t>6 390</a:t>
                       </a:r>
                     </a:p>
                   </a:txBody>
@@ -23284,7 +23284,7 @@
                             <a:srgbClr val="1A1A1A"/>
                           </a:solidFill>
                         </a:rPr>
-                        <a:t>-6.7%</a:t>
+                        <a:t>-6.8%</a:t>
                       </a:r>
                     </a:p>
                   </a:txBody>
@@ -24847,7 +24847,7 @@
                   <a:srgbClr val="555555"/>
                 </a:solidFill>
               </a:rPr>
-              <a:t>Le P/E Forward a 21.5x s'inscrit en prime de 18% par rapport a la mediane 10 ans (18.2x), justifie en partie par la monetisation de l'IA et la qualite superieure des marges. L'ERP ressort a 4.2% — niveau attractif mais contraint par le 10Y US a 4.3%. La compression de multiple reste le principal risque si les taux LT d</a:t>
+              <a:t>Le P/E Forward a 21.5x s'inscrit en prime de 18% par rapport a la mediane 10 ans (18.2x), justifie en partie par la monetisation de l'IA et la qualite superieure des marges. L'ERP ressort a 4.2% — niveau attractif mais contraint par le 10Y US a 4.3%. La compression de multiple reste le principal risque si les taux LT...</a:t>
             </a:r>
           </a:p>
         </p:txBody>
@@ -25694,7 +25694,7 @@
                   <a:srgbClr val="AAAAAA"/>
                 </a:solidFill>
               </a:rPr>
-              <a:t>L'analyse des indicateurs avancees positionne le cycle en phase d'expansion avancee : ISM Manufacturier autour du seuil 50 (49.8), courbe des taux partiellement normalisee (10Y-2Y +0.2%), Leading Indicators OCDE en legere hausse. Cette configuration favorise les secteurs avec for</a:t>
+              <a:t>L'analyse des indicateurs avancees positionne le cycle en phase d'expansion avancee : ISM Manufacturier autour du seuil 50 (49.8), courbe...</a:t>
             </a:r>
           </a:p>
         </p:txBody>
@@ -26265,7 +26265,7 @@
                   <a:srgbClr val="555555"/>
                 </a:solidFill>
               </a:rPr>
-              <a:t>L'analyse des indicateurs avancees positionne le cycle en phase d'expansion avancee : ISM Manufacturier autour du seuil 50 (49.8), courbe des taux partiellement normalisee (10Y-2Y +0.2%), Leading Indi</a:t>
+              <a:t>L'analyse des indicateurs avancees positionne le cycle en phase d'expansion avancee : ISM Manufacturier autour du seuil 50 (49.8), courbe des taux partiellement normalisee (10Y-2Y +0.2%), Leading...</a:t>
             </a:r>
           </a:p>
         </p:txBody>
@@ -27422,7 +27422,7 @@
                             <a:srgbClr val="1A1A1A"/>
                           </a:solidFill>
                         </a:rPr>
-                        <a:t>22.0%</a:t>
+                        <a:t>24.0%</a:t>
                       </a:r>
                     </a:p>
                   </a:txBody>
@@ -27442,7 +27442,7 @@
                             <a:srgbClr val="1A1A1A"/>
                           </a:solidFill>
                         </a:rPr>
-                        <a:t>+8.0%</a:t>
+                        <a:t>-1.5%</a:t>
                       </a:r>
                     </a:p>
                   </a:txBody>
@@ -27594,7 +27594,7 @@
                             <a:srgbClr val="1A1A1A"/>
                           </a:solidFill>
                         </a:rPr>
-                        <a:t>22.0%</a:t>
+                        <a:t>27.0%</a:t>
                       </a:r>
                     </a:p>
                   </a:txBody>
@@ -27616,7 +27616,7 @@
                             <a:srgbClr val="1A1A1A"/>
                           </a:solidFill>
                         </a:rPr>
-                        <a:t>+8.0%</a:t>
+                        <a:t>+13.0%</a:t>
                       </a:r>
                     </a:p>
                   </a:txBody>
@@ -27638,7 +27638,7 @@
                             <a:srgbClr val="1A1A1A"/>
                           </a:solidFill>
                         </a:rPr>
-                        <a:t>+25.0%</a:t>
+                        <a:t>+24.6%</a:t>
                       </a:r>
                     </a:p>
                   </a:txBody>
@@ -27764,7 +27764,7 @@
                             <a:srgbClr val="1A1A1A"/>
                           </a:solidFill>
                         </a:rPr>
-                        <a:t>22.0%</a:t>
+                        <a:t>14.0%</a:t>
                       </a:r>
                     </a:p>
                   </a:txBody>
@@ -27784,7 +27784,7 @@
                             <a:srgbClr val="1A1A1A"/>
                           </a:solidFill>
                         </a:rPr>
-                        <a:t>+8.0%</a:t>
+                        <a:t>+6.5%</a:t>
                       </a:r>
                     </a:p>
                   </a:txBody>
@@ -27804,7 +27804,7 @@
                             <a:srgbClr val="1A1A1A"/>
                           </a:solidFill>
                         </a:rPr>
-                        <a:t>+23.7%</a:t>
+                        <a:t>+23.3%</a:t>
                       </a:r>
                     </a:p>
                   </a:txBody>
@@ -27936,7 +27936,7 @@
                             <a:srgbClr val="1A1A1A"/>
                           </a:solidFill>
                         </a:rPr>
-                        <a:t>22.0%</a:t>
+                        <a:t>28.0%</a:t>
                       </a:r>
                     </a:p>
                   </a:txBody>
@@ -27958,7 +27958,7 @@
                             <a:srgbClr val="1A1A1A"/>
                           </a:solidFill>
                         </a:rPr>
-                        <a:t>+8.0%</a:t>
+                        <a:t>+2.5%</a:t>
                       </a:r>
                     </a:p>
                   </a:txBody>
@@ -27980,7 +27980,7 @@
                             <a:srgbClr val="1A1A1A"/>
                           </a:solidFill>
                         </a:rPr>
-                        <a:t>+19.7%</a:t>
+                        <a:t>+19.8%</a:t>
                       </a:r>
                     </a:p>
                   </a:txBody>
@@ -28106,7 +28106,7 @@
                             <a:srgbClr val="1A1A1A"/>
                           </a:solidFill>
                         </a:rPr>
-                        <a:t>22.0%</a:t>
+                        <a:t>16.0%</a:t>
                       </a:r>
                     </a:p>
                   </a:txBody>
@@ -28126,7 +28126,7 @@
                             <a:srgbClr val="1A1A1A"/>
                           </a:solidFill>
                         </a:rPr>
-                        <a:t>+8.0%</a:t>
+                        <a:t>+4.0%</a:t>
                       </a:r>
                     </a:p>
                   </a:txBody>
@@ -28278,7 +28278,7 @@
                             <a:srgbClr val="1A1A1A"/>
                           </a:solidFill>
                         </a:rPr>
-                        <a:t>22.0%</a:t>
+                        <a:t>18.0%</a:t>
                       </a:r>
                     </a:p>
                   </a:txBody>
@@ -28300,7 +28300,7 @@
                             <a:srgbClr val="1A1A1A"/>
                           </a:solidFill>
                         </a:rPr>
-                        <a:t>+8.0%</a:t>
+                        <a:t>+6.0%</a:t>
                       </a:r>
                     </a:p>
                   </a:txBody>
@@ -28322,7 +28322,7 @@
                             <a:srgbClr val="1A1A1A"/>
                           </a:solidFill>
                         </a:rPr>
-                        <a:t>+13.7%</a:t>
+                        <a:t>+13.4%</a:t>
                       </a:r>
                     </a:p>
                   </a:txBody>
@@ -28448,7 +28448,7 @@
                             <a:srgbClr val="1A1A1A"/>
                           </a:solidFill>
                         </a:rPr>
-                        <a:t>22.0%</a:t>
+                        <a:t>18.0%</a:t>
                       </a:r>
                     </a:p>
                   </a:txBody>
@@ -28468,7 +28468,7 @@
                             <a:srgbClr val="1A1A1A"/>
                           </a:solidFill>
                         </a:rPr>
-                        <a:t>+8.0%</a:t>
+                        <a:t>+6.0%</a:t>
                       </a:r>
                     </a:p>
                   </a:txBody>
@@ -28488,7 +28488,7 @@
                             <a:srgbClr val="1A1A1A"/>
                           </a:solidFill>
                         </a:rPr>
-                        <a:t>+8.7%</a:t>
+                        <a:t>+8.4%</a:t>
                       </a:r>
                     </a:p>
                   </a:txBody>
@@ -28620,7 +28620,7 @@
                             <a:srgbClr val="1A1A1A"/>
                           </a:solidFill>
                         </a:rPr>
-                        <a:t>22.0%</a:t>
+                        <a:t>18.0%</a:t>
                       </a:r>
                     </a:p>
                   </a:txBody>
@@ -28642,7 +28642,7 @@
                             <a:srgbClr val="1A1A1A"/>
                           </a:solidFill>
                         </a:rPr>
-                        <a:t>+8.0%</a:t>
+                        <a:t>+9.5%</a:t>
                       </a:r>
                     </a:p>
                   </a:txBody>
@@ -28664,7 +28664,7 @@
                             <a:srgbClr val="1A1A1A"/>
                           </a:solidFill>
                         </a:rPr>
-                        <a:t>+4.4%</a:t>
+                        <a:t>+4.5%</a:t>
                       </a:r>
                     </a:p>
                   </a:txBody>
@@ -28708,7 +28708,7 @@
                             <a:srgbClr val="1A1A1A"/>
                           </a:solidFill>
                         </a:rPr>
-                        <a:t>Consumer Staples</a:t>
+                        <a:t>Cons. Staples</a:t>
                       </a:r>
                     </a:p>
                   </a:txBody>
@@ -28790,7 +28790,7 @@
                             <a:srgbClr val="1A1A1A"/>
                           </a:solidFill>
                         </a:rPr>
-                        <a:t>22.0%</a:t>
+                        <a:t>17.0%</a:t>
                       </a:r>
                     </a:p>
                   </a:txBody>
@@ -28810,7 +28810,7 @@
                             <a:srgbClr val="1A1A1A"/>
                           </a:solidFill>
                         </a:rPr>
-                        <a:t>+8.0%</a:t>
+                        <a:t>+3.5%</a:t>
                       </a:r>
                     </a:p>
                   </a:txBody>
@@ -28830,7 +28830,7 @@
                             <a:srgbClr val="1A1A1A"/>
                           </a:solidFill>
                         </a:rPr>
-                        <a:t>+3.2%</a:t>
+                        <a:t>+3.4%</a:t>
                       </a:r>
                     </a:p>
                   </a:txBody>
@@ -28962,7 +28962,7 @@
                             <a:srgbClr val="1A1A1A"/>
                           </a:solidFill>
                         </a:rPr>
-                        <a:t>22.0%</a:t>
+                        <a:t>42.0%</a:t>
                       </a:r>
                     </a:p>
                   </a:txBody>
@@ -28984,7 +28984,7 @@
                             <a:srgbClr val="1A1A1A"/>
                           </a:solidFill>
                         </a:rPr>
-                        <a:t>+8.0%</a:t>
+                        <a:t>+2.0%</a:t>
                       </a:r>
                     </a:p>
                   </a:txBody>
@@ -29006,7 +29006,7 @@
                             <a:srgbClr val="1A1A1A"/>
                           </a:solidFill>
                         </a:rPr>
-                        <a:t>+0.8%</a:t>
+                        <a:t>+0.9%</a:t>
                       </a:r>
                     </a:p>
                   </a:txBody>
@@ -29132,7 +29132,7 @@
                             <a:srgbClr val="1A1A1A"/>
                           </a:solidFill>
                         </a:rPr>
-                        <a:t>22.0%</a:t>
+                        <a:t>30.0%</a:t>
                       </a:r>
                     </a:p>
                   </a:txBody>
@@ -29152,7 +29152,7 @@
                             <a:srgbClr val="1A1A1A"/>
                           </a:solidFill>
                         </a:rPr>
-                        <a:t>+8.0%</a:t>
+                        <a:t>+10.0%</a:t>
                       </a:r>
                     </a:p>
                   </a:txBody>

</xml_diff>